<commit_message>
future builds: database, sign-in memory, status per theme, weekly notes, more sources, account and trend views
</commit_message>
<xml_diff>
--- a/deck/Feature-Bug-Requests.pptx
+++ b/deck/Feature-Bug-Requests.pptx
@@ -1036,7 +1036,7 @@
           <a:p>
             <a:r>
               <a:rPr lang="en-US" dirty="0"/>
-              <a:t>Scope. Built only what the brief asked for. PII scrub, live connectors, evals and an approve gate before a backlog are designed and shown here, not built.</a:t>
+              <a:t>Scope. Built only what the brief asked for. PII scrub, live connectors, evals and an approve gate are drawn on the system; a database, sign-in with memory, status per theme, weekly notes, more sources, per-account and trend views are listed for later. None of it is built.</a:t>
             </a:r>
             <a:endParaRPr lang="en-US" dirty="0"/>
           </a:p>
@@ -2300,7 +2300,7 @@
                 <a:ea typeface="Arial" pitchFamily="34" charset="-122"/>
                 <a:cs typeface="Arial" pitchFamily="34" charset="-120"/>
               </a:rPr>
-              <a:t>Built to the brief; four add-ons are designed, not built</a:t>
+              <a:t>Built to the brief; everything else is designed, not built</a:t>
             </a:r>
             <a:endParaRPr lang="en-US" sz="2200" dirty="0"/>
           </a:p>
@@ -2323,7 +2323,7 @@
         <p:spPr>
           <a:xfrm>
             <a:off x="548640" y="1417320"/>
-            <a:ext cx="7159413" cy="3291840"/>
+            <a:ext cx="8046720" cy="2613320"/>
           </a:xfrm>
           <a:prstGeom prst="rect">
             <a:avLst/>

</xml_diff>

<commit_message>
deck: appendix slide with the decisions behind the build
</commit_message>
<xml_diff>
--- a/deck/Feature-Bug-Requests.pptx
+++ b/deck/Feature-Bug-Requests.pptx
@@ -12,9 +12,10 @@
     <p:sldId id="260" r:id="rId6"/>
     <p:sldId id="261" r:id="rId7"/>
     <p:sldId id="262" r:id="rId8"/>
+    <p:sldId id="263" r:id="rId9"/>
   </p:sldIdLst>
   <p:notesMasterIdLst>
-    <p:notesMasterId r:id="rId9"/>
+    <p:notesMasterId r:id="rId10"/>
   </p:notesMasterIdLst>
   <p:sldSz cx="9144000" cy="5143500"/>
   <p:notesSz cx="5143500" cy="9144000"/>
@@ -1060,6 +1061,94 @@
             <a:fld id="{F7021451-1387-4CA6-816F-3879F97B5CBC}" type="slidenum">
               <a:rPr lang="en-US"/>
               <a:t>7</a:t>
+            </a:fld>
+            <a:endParaRPr lang="en-US"/>
+          </a:p>
+        </p:txBody>
+      </p:sp>
+    </p:spTree>
+    <p:extLst>
+      <p:ext uri="{BB962C8B-B14F-4D97-AF65-F5344CB8AC3E}">
+        <p14:creationId xmlns:p14="http://schemas.microsoft.com/office/powerpoint/2010/main" val="1024086991"/>
+      </p:ext>
+    </p:extLst>
+  </p:cSld>
+  <p:clrMapOvr>
+    <a:masterClrMapping/>
+  </p:clrMapOvr>
+</p:notes>
+</file>
+
+<file path=ppt/notesSlides/notesSlide8.xml><?xml version="1.0" encoding="utf-8"?>
+<p:notes xmlns:a="http://schemas.openxmlformats.org/drawingml/2006/main" xmlns:r="http://schemas.openxmlformats.org/officeDocument/2006/relationships" xmlns:p="http://schemas.openxmlformats.org/presentationml/2006/main">
+  <p:cSld>
+    <p:spTree>
+      <p:nvGrpSpPr>
+        <p:cNvPr id="1" name=""/>
+        <p:cNvGrpSpPr/>
+        <p:nvPr/>
+      </p:nvGrpSpPr>
+      <p:grpSpPr>
+        <a:xfrm>
+          <a:off x="0" y="0"/>
+          <a:ext cx="0" cy="0"/>
+          <a:chOff x="0" y="0"/>
+          <a:chExt cx="0" cy="0"/>
+        </a:xfrm>
+      </p:grpSpPr>
+      <p:sp>
+        <p:nvSpPr>
+          <p:cNvPr id="2" name="Slide Image Placeholder 1"/>
+          <p:cNvSpPr>
+            <a:spLocks noGrp="1" noRot="1" noChangeAspect="1"/>
+          </p:cNvSpPr>
+          <p:nvPr>
+            <p:ph type="sldImg"/>
+          </p:nvPr>
+        </p:nvSpPr>
+        <p:spPr/>
+      </p:sp>
+      <p:sp>
+        <p:nvSpPr>
+          <p:cNvPr id="3" name="Notes Placeholder 2"/>
+          <p:cNvSpPr>
+            <a:spLocks noGrp="1"/>
+          </p:cNvSpPr>
+          <p:nvPr>
+            <p:ph type="body" idx="1"/>
+          </p:nvPr>
+        </p:nvSpPr>
+        <p:spPr/>
+        <p:txBody>
+          <a:bodyPr/>
+          <a:lstStyle/>
+          <a:p>
+            <a:r>
+              <a:rPr lang="en-US" dirty="0"/>
+              <a:t>Appendix. The stack, the model tiers, the size of the mock data, the checks in code, the hosting, and the first week of real numbers. Every one of these was a choice; the point is that nothing here is accidental.</a:t>
+            </a:r>
+            <a:endParaRPr lang="en-US" dirty="0"/>
+          </a:p>
+        </p:txBody>
+      </p:sp>
+      <p:sp>
+        <p:nvSpPr>
+          <p:cNvPr id="4" name="Slide Number Placeholder 3"/>
+          <p:cNvSpPr>
+            <a:spLocks noGrp="1"/>
+          </p:cNvSpPr>
+          <p:nvPr>
+            <p:ph type="sldNum" sz="quarter" idx="10"/>
+          </p:nvPr>
+        </p:nvSpPr>
+        <p:spPr/>
+        <p:txBody>
+          <a:bodyPr/>
+          <a:lstStyle/>
+          <a:p>
+            <a:fld id="{F7021451-1387-4CA6-816F-3879F97B5CBC}" type="slidenum">
+              <a:rPr lang="en-US"/>
+              <a:t>8</a:t>
             </a:fld>
             <a:endParaRPr lang="en-US"/>
           </a:p>
@@ -2338,6 +2427,140 @@
 </p:sld>
 </file>
 
+<file path=ppt/slides/slide8.xml><?xml version="1.0" encoding="utf-8"?>
+<p:sld xmlns:a="http://schemas.openxmlformats.org/drawingml/2006/main" xmlns:r="http://schemas.openxmlformats.org/officeDocument/2006/relationships" xmlns:p="http://schemas.openxmlformats.org/presentationml/2006/main">
+  <p:cSld name="Slide 8">
+    <p:bg>
+      <p:bgPr>
+        <a:solidFill>
+          <a:srgbClr val="FFFFFF"/>
+        </a:solidFill>
+      </p:bgPr>
+    </p:bg>
+    <p:spTree>
+      <p:nvGrpSpPr>
+        <p:cNvPr id="1" name=""/>
+        <p:cNvGrpSpPr/>
+        <p:nvPr/>
+      </p:nvGrpSpPr>
+      <p:grpSpPr>
+        <a:xfrm>
+          <a:off x="0" y="0"/>
+          <a:ext cx="0" cy="0"/>
+          <a:chOff x="0" y="0"/>
+          <a:chExt cx="0" cy="0"/>
+        </a:xfrm>
+      </p:grpSpPr>
+      <p:sp>
+        <p:nvSpPr>
+          <p:cNvPr id="2" name="Text 0"/>
+          <p:cNvSpPr txBox="1"/>
+          <p:nvPr/>
+        </p:nvSpPr>
+        <p:spPr>
+          <a:xfrm>
+            <a:off x="8412480" y="182880"/>
+            <a:ext cx="457200" cy="274320"/>
+          </a:xfrm>
+          <a:prstGeom prst="rect">
+            <a:avLst/>
+          </a:prstGeom>
+          <a:noFill/>
+          <a:ln/>
+        </p:spPr>
+        <p:txBody>
+          <a:bodyPr wrap="square" lIns="0" tIns="0" rIns="0" bIns="0" rtlCol="0" anchor="ctr"/>
+          <a:lstStyle/>
+          <a:p>
+            <a:pPr algn="r" indent="0" marL="0">
+              <a:buNone/>
+            </a:pPr>
+            <a:r>
+              <a:rPr lang="en-US" sz="1000" dirty="0">
+                <a:solidFill>
+                  <a:srgbClr val="888780"/>
+                </a:solidFill>
+                <a:latin typeface="Arial" pitchFamily="34" charset="0"/>
+                <a:ea typeface="Arial" pitchFamily="34" charset="-122"/>
+                <a:cs typeface="Arial" pitchFamily="34" charset="-120"/>
+              </a:rPr>
+              <a:t>8</a:t>
+            </a:r>
+            <a:endParaRPr lang="en-US" sz="1000" dirty="0"/>
+          </a:p>
+        </p:txBody>
+      </p:sp>
+      <p:sp>
+        <p:nvSpPr>
+          <p:cNvPr id="3" name="Text 1"/>
+          <p:cNvSpPr txBox="1"/>
+          <p:nvPr/>
+        </p:nvSpPr>
+        <p:spPr>
+          <a:xfrm>
+            <a:off x="548640" y="411480"/>
+            <a:ext cx="8046720" cy="868680"/>
+          </a:xfrm>
+          <a:prstGeom prst="rect">
+            <a:avLst/>
+          </a:prstGeom>
+          <a:noFill/>
+          <a:ln/>
+        </p:spPr>
+        <p:txBody>
+          <a:bodyPr wrap="square" lIns="0" tIns="0" rIns="0" bIns="0" rtlCol="0" anchor="t"/>
+          <a:lstStyle/>
+          <a:p>
+            <a:pPr indent="0" marL="0">
+              <a:buNone/>
+            </a:pPr>
+            <a:r>
+              <a:rPr lang="en-US" sz="2200" dirty="0">
+                <a:solidFill>
+                  <a:srgbClr val="2C2C2A"/>
+                </a:solidFill>
+                <a:latin typeface="Arial" pitchFamily="34" charset="0"/>
+                <a:ea typeface="Arial" pitchFamily="34" charset="-122"/>
+                <a:cs typeface="Arial" pitchFamily="34" charset="-120"/>
+              </a:rPr>
+              <a:t>Appendix: the decisions behind it</a:t>
+            </a:r>
+            <a:endParaRPr lang="en-US" sz="2200" dirty="0"/>
+          </a:p>
+        </p:txBody>
+      </p:sp>
+      <p:pic>
+        <p:nvPicPr>
+          <p:cNvPr id="4" name="Image 0" descr="png/body/slide-8.png">    </p:cNvPr>
+          <p:cNvPicPr>
+            <a:picLocks noChangeAspect="1"/>
+          </p:cNvPicPr>
+          <p:nvPr/>
+        </p:nvPicPr>
+        <p:blipFill>
+          <a:blip r:embed="rId1"/>
+          <a:stretch>
+            <a:fillRect/>
+          </a:stretch>
+        </p:blipFill>
+        <p:spPr>
+          <a:xfrm>
+            <a:off x="548640" y="1417320"/>
+            <a:ext cx="6326268" cy="3291840"/>
+          </a:xfrm>
+          <a:prstGeom prst="rect">
+            <a:avLst/>
+          </a:prstGeom>
+        </p:spPr>
+      </p:pic>
+    </p:spTree>
+  </p:cSld>
+  <p:clrMapOvr>
+    <a:masterClrMapping/>
+  </p:clrMapOvr>
+</p:sld>
+</file>
+
 <file path=ppt/theme/theme1.xml><?xml version="1.0" encoding="utf-8"?>
 <a:theme xmlns:a="http://schemas.openxmlformats.org/drawingml/2006/main" name="Office Theme">
   <a:themeElements>

</xml_diff>

<commit_message>
deck: roadmap slide in four groups
</commit_message>
<xml_diff>
--- a/deck/Feature-Bug-Requests.pptx
+++ b/deck/Feature-Bug-Requests.pptx
@@ -2389,7 +2389,7 @@
                 <a:ea typeface="Arial" pitchFamily="34" charset="-122"/>
                 <a:cs typeface="Arial" pitchFamily="34" charset="-120"/>
               </a:rPr>
-              <a:t>Built to the brief; everything else is designed, not built</a:t>
+              <a:t>Built to the brief; the next steps are designed, not built</a:t>
             </a:r>
             <a:endParaRPr lang="en-US" sz="2200" dirty="0"/>
           </a:p>
@@ -2412,7 +2412,7 @@
         <p:spPr>
           <a:xfrm>
             <a:off x="548640" y="1417320"/>
-            <a:ext cx="8046720" cy="2613320"/>
+            <a:ext cx="7085575" cy="3291840"/>
           </a:xfrm>
           <a:prstGeom prst="rect">
             <a:avLst/>

</xml_diff>

<commit_message>
readers and editor answer only through a schema: forced tool call, code still verifies every quote
</commit_message>
<xml_diff>
--- a/deck/Feature-Bug-Requests.pptx
+++ b/deck/Feature-Bug-Requests.pptx
@@ -1125,7 +1125,7 @@
           <a:p>
             <a:r>
               <a:rPr lang="en-US" dirty="0"/>
-              <a:t>Appendix. The stack, the model tiers, the size of the mock data, the checks in code, the hosting, and the first week of real numbers. Every one of these was a choice; the point is that nothing here is accidental.</a:t>
+              <a:t>Appendix. The stack, the model tiers, the size of the mock data, the checks in code including that every agent answers only through a schema, the hosting, and the first week of real numbers. Every one of these was a choice; the point is that nothing here is accidental.</a:t>
             </a:r>
             <a:endParaRPr lang="en-US" dirty="0"/>
           </a:p>
@@ -2546,7 +2546,7 @@
         <p:spPr>
           <a:xfrm>
             <a:off x="548640" y="1417320"/>
-            <a:ext cx="6326268" cy="3291840"/>
+            <a:ext cx="6762354" cy="3291840"/>
           </a:xfrm>
           <a:prstGeom prst="rect">
             <a:avLst/>

</xml_diff>

<commit_message>
deck: the panel's questions answered on slide 7; readme images
</commit_message>
<xml_diff>
--- a/deck/Feature-Bug-Requests.pptx
+++ b/deck/Feature-Bug-Requests.pptx
@@ -13,9 +13,10 @@
     <p:sldId id="261" r:id="rId7"/>
     <p:sldId id="262" r:id="rId8"/>
     <p:sldId id="263" r:id="rId9"/>
+    <p:sldId id="264" r:id="rId10"/>
   </p:sldIdLst>
   <p:notesMasterIdLst>
-    <p:notesMasterId r:id="rId10"/>
+    <p:notesMasterId r:id="rId11"/>
   </p:notesMasterIdLst>
   <p:sldSz cx="9144000" cy="5143500"/>
   <p:notesSz cx="5143500" cy="9144000"/>
@@ -1037,7 +1038,7 @@
           <a:p>
             <a:r>
               <a:rPr lang="en-US" dirty="0"/>
-              <a:t>Scope. Built only what the brief asked for. PII scrub, live connectors, evals and an approve gate are drawn on the system; a database, sign-in with memory, status per theme, weekly notes, more sources, per-account and trend views are listed for later. None of it is built.</a:t>
+              <a:t>The questions from the panel, answered in the build. Where the context lives between runs, where the agents run and when Bedrock is the right swap, what an agent can see and do and how it is audited, the PII scrub before any reader, the golden set against drift, the library as plain files, and the cost on every run.</a:t>
             </a:r>
             <a:endParaRPr lang="en-US" dirty="0"/>
           </a:p>
@@ -1125,7 +1126,7 @@
           <a:p>
             <a:r>
               <a:rPr lang="en-US" dirty="0"/>
-              <a:t>Appendix. The stack, the model tiers, the size of the mock data, the checks in code including that every agent answers only through a schema, the hosting, and the first week of real numbers. Every one of these was a choice; the point is that nothing here is accidental.</a:t>
+              <a:t>Scope. Built only what the brief asked for. A wider scrub, a wider golden set, live connectors and an approve gate are drawn on the system; a database, sign-in with memory, status per theme, weekly notes, more sources, per-account and trend views are listed for later. None of it is built.</a:t>
             </a:r>
             <a:endParaRPr lang="en-US" dirty="0"/>
           </a:p>
@@ -1149,6 +1150,94 @@
             <a:fld id="{F7021451-1387-4CA6-816F-3879F97B5CBC}" type="slidenum">
               <a:rPr lang="en-US"/>
               <a:t>8</a:t>
+            </a:fld>
+            <a:endParaRPr lang="en-US"/>
+          </a:p>
+        </p:txBody>
+      </p:sp>
+    </p:spTree>
+    <p:extLst>
+      <p:ext uri="{BB962C8B-B14F-4D97-AF65-F5344CB8AC3E}">
+        <p14:creationId xmlns:p14="http://schemas.microsoft.com/office/powerpoint/2010/main" val="1024086991"/>
+      </p:ext>
+    </p:extLst>
+  </p:cSld>
+  <p:clrMapOvr>
+    <a:masterClrMapping/>
+  </p:clrMapOvr>
+</p:notes>
+</file>
+
+<file path=ppt/notesSlides/notesSlide9.xml><?xml version="1.0" encoding="utf-8"?>
+<p:notes xmlns:a="http://schemas.openxmlformats.org/drawingml/2006/main" xmlns:r="http://schemas.openxmlformats.org/officeDocument/2006/relationships" xmlns:p="http://schemas.openxmlformats.org/presentationml/2006/main">
+  <p:cSld>
+    <p:spTree>
+      <p:nvGrpSpPr>
+        <p:cNvPr id="1" name=""/>
+        <p:cNvGrpSpPr/>
+        <p:nvPr/>
+      </p:nvGrpSpPr>
+      <p:grpSpPr>
+        <a:xfrm>
+          <a:off x="0" y="0"/>
+          <a:ext cx="0" cy="0"/>
+          <a:chOff x="0" y="0"/>
+          <a:chExt cx="0" cy="0"/>
+        </a:xfrm>
+      </p:grpSpPr>
+      <p:sp>
+        <p:nvSpPr>
+          <p:cNvPr id="2" name="Slide Image Placeholder 1"/>
+          <p:cNvSpPr>
+            <a:spLocks noGrp="1" noRot="1" noChangeAspect="1"/>
+          </p:cNvSpPr>
+          <p:nvPr>
+            <p:ph type="sldImg"/>
+          </p:nvPr>
+        </p:nvSpPr>
+        <p:spPr/>
+      </p:sp>
+      <p:sp>
+        <p:nvSpPr>
+          <p:cNvPr id="3" name="Notes Placeholder 2"/>
+          <p:cNvSpPr>
+            <a:spLocks noGrp="1"/>
+          </p:cNvSpPr>
+          <p:nvPr>
+            <p:ph type="body" idx="1"/>
+          </p:nvPr>
+        </p:nvSpPr>
+        <p:spPr/>
+        <p:txBody>
+          <a:bodyPr/>
+          <a:lstStyle/>
+          <a:p>
+            <a:r>
+              <a:rPr lang="en-US" dirty="0"/>
+              <a:t>Appendix. The stack, the model tiers, the size of the mock data, the checks in code including that every agent answers only through a schema, the hosting, and the first week of real numbers. Every one of these was a choice; the point is that nothing here is accidental.</a:t>
+            </a:r>
+            <a:endParaRPr lang="en-US" dirty="0"/>
+          </a:p>
+        </p:txBody>
+      </p:sp>
+      <p:sp>
+        <p:nvSpPr>
+          <p:cNvPr id="4" name="Slide Number Placeholder 3"/>
+          <p:cNvSpPr>
+            <a:spLocks noGrp="1"/>
+          </p:cNvSpPr>
+          <p:nvPr>
+            <p:ph type="sldNum" sz="quarter" idx="10"/>
+          </p:nvPr>
+        </p:nvSpPr>
+        <p:spPr/>
+        <p:txBody>
+          <a:bodyPr/>
+          <a:lstStyle/>
+          <a:p>
+            <a:fld id="{F7021451-1387-4CA6-816F-3879F97B5CBC}" type="slidenum">
+              <a:rPr lang="en-US"/>
+              <a:t>9</a:t>
             </a:fld>
             <a:endParaRPr lang="en-US"/>
           </a:p>
@@ -2389,7 +2478,7 @@
                 <a:ea typeface="Arial" pitchFamily="34" charset="-122"/>
                 <a:cs typeface="Arial" pitchFamily="34" charset="-120"/>
               </a:rPr>
-              <a:t>Built to the brief; the next steps are designed, not built</a:t>
+              <a:t>The questions from our conversation, and where each answer lives</a:t>
             </a:r>
             <a:endParaRPr lang="en-US" sz="2200" dirty="0"/>
           </a:p>
@@ -2412,7 +2501,7 @@
         <p:spPr>
           <a:xfrm>
             <a:off x="548640" y="1417320"/>
-            <a:ext cx="7085575" cy="3291840"/>
+            <a:ext cx="5407540" cy="3291840"/>
           </a:xfrm>
           <a:prstGeom prst="rect">
             <a:avLst/>
@@ -2523,7 +2612,7 @@
                 <a:ea typeface="Arial" pitchFamily="34" charset="-122"/>
                 <a:cs typeface="Arial" pitchFamily="34" charset="-120"/>
               </a:rPr>
-              <a:t>Appendix: the decisions behind it</a:t>
+              <a:t>Built to the brief; the next steps are designed, not built</a:t>
             </a:r>
             <a:endParaRPr lang="en-US" sz="2200" dirty="0"/>
           </a:p>
@@ -2532,6 +2621,140 @@
       <p:pic>
         <p:nvPicPr>
           <p:cNvPr id="4" name="Image 0" descr="png/body/slide-8.png">    </p:cNvPr>
+          <p:cNvPicPr>
+            <a:picLocks noChangeAspect="1"/>
+          </p:cNvPicPr>
+          <p:nvPr/>
+        </p:nvPicPr>
+        <p:blipFill>
+          <a:blip r:embed="rId1"/>
+          <a:stretch>
+            <a:fillRect/>
+          </a:stretch>
+        </p:blipFill>
+        <p:spPr>
+          <a:xfrm>
+            <a:off x="548640" y="1417320"/>
+            <a:ext cx="7085575" cy="3291840"/>
+          </a:xfrm>
+          <a:prstGeom prst="rect">
+            <a:avLst/>
+          </a:prstGeom>
+        </p:spPr>
+      </p:pic>
+    </p:spTree>
+  </p:cSld>
+  <p:clrMapOvr>
+    <a:masterClrMapping/>
+  </p:clrMapOvr>
+</p:sld>
+</file>
+
+<file path=ppt/slides/slide9.xml><?xml version="1.0" encoding="utf-8"?>
+<p:sld xmlns:a="http://schemas.openxmlformats.org/drawingml/2006/main" xmlns:r="http://schemas.openxmlformats.org/officeDocument/2006/relationships" xmlns:p="http://schemas.openxmlformats.org/presentationml/2006/main">
+  <p:cSld name="Slide 9">
+    <p:bg>
+      <p:bgPr>
+        <a:solidFill>
+          <a:srgbClr val="FFFFFF"/>
+        </a:solidFill>
+      </p:bgPr>
+    </p:bg>
+    <p:spTree>
+      <p:nvGrpSpPr>
+        <p:cNvPr id="1" name=""/>
+        <p:cNvGrpSpPr/>
+        <p:nvPr/>
+      </p:nvGrpSpPr>
+      <p:grpSpPr>
+        <a:xfrm>
+          <a:off x="0" y="0"/>
+          <a:ext cx="0" cy="0"/>
+          <a:chOff x="0" y="0"/>
+          <a:chExt cx="0" cy="0"/>
+        </a:xfrm>
+      </p:grpSpPr>
+      <p:sp>
+        <p:nvSpPr>
+          <p:cNvPr id="2" name="Text 0"/>
+          <p:cNvSpPr txBox="1"/>
+          <p:nvPr/>
+        </p:nvSpPr>
+        <p:spPr>
+          <a:xfrm>
+            <a:off x="8412480" y="182880"/>
+            <a:ext cx="457200" cy="274320"/>
+          </a:xfrm>
+          <a:prstGeom prst="rect">
+            <a:avLst/>
+          </a:prstGeom>
+          <a:noFill/>
+          <a:ln/>
+        </p:spPr>
+        <p:txBody>
+          <a:bodyPr wrap="square" lIns="0" tIns="0" rIns="0" bIns="0" rtlCol="0" anchor="ctr"/>
+          <a:lstStyle/>
+          <a:p>
+            <a:pPr algn="r" indent="0" marL="0">
+              <a:buNone/>
+            </a:pPr>
+            <a:r>
+              <a:rPr lang="en-US" sz="1000" dirty="0">
+                <a:solidFill>
+                  <a:srgbClr val="888780"/>
+                </a:solidFill>
+                <a:latin typeface="Arial" pitchFamily="34" charset="0"/>
+                <a:ea typeface="Arial" pitchFamily="34" charset="-122"/>
+                <a:cs typeface="Arial" pitchFamily="34" charset="-120"/>
+              </a:rPr>
+              <a:t>9</a:t>
+            </a:r>
+            <a:endParaRPr lang="en-US" sz="1000" dirty="0"/>
+          </a:p>
+        </p:txBody>
+      </p:sp>
+      <p:sp>
+        <p:nvSpPr>
+          <p:cNvPr id="3" name="Text 1"/>
+          <p:cNvSpPr txBox="1"/>
+          <p:nvPr/>
+        </p:nvSpPr>
+        <p:spPr>
+          <a:xfrm>
+            <a:off x="548640" y="411480"/>
+            <a:ext cx="8046720" cy="868680"/>
+          </a:xfrm>
+          <a:prstGeom prst="rect">
+            <a:avLst/>
+          </a:prstGeom>
+          <a:noFill/>
+          <a:ln/>
+        </p:spPr>
+        <p:txBody>
+          <a:bodyPr wrap="square" lIns="0" tIns="0" rIns="0" bIns="0" rtlCol="0" anchor="t"/>
+          <a:lstStyle/>
+          <a:p>
+            <a:pPr indent="0" marL="0">
+              <a:buNone/>
+            </a:pPr>
+            <a:r>
+              <a:rPr lang="en-US" sz="2200" dirty="0">
+                <a:solidFill>
+                  <a:srgbClr val="2C2C2A"/>
+                </a:solidFill>
+                <a:latin typeface="Arial" pitchFamily="34" charset="0"/>
+                <a:ea typeface="Arial" pitchFamily="34" charset="-122"/>
+                <a:cs typeface="Arial" pitchFamily="34" charset="-120"/>
+              </a:rPr>
+              <a:t>Appendix: the decisions behind it</a:t>
+            </a:r>
+            <a:endParaRPr lang="en-US" sz="2200" dirty="0"/>
+          </a:p>
+        </p:txBody>
+      </p:sp>
+      <p:pic>
+        <p:nvPicPr>
+          <p:cNvPr id="4" name="Image 0" descr="png/body/slide-9.png">    </p:cNvPr>
           <p:cNvPicPr>
             <a:picLocks noChangeAspect="1"/>
           </p:cNvPicPr>

</xml_diff>

<commit_message>
deck: guardrails shown where the data passes them, no question slide
</commit_message>
<xml_diff>
--- a/deck/Feature-Bug-Requests.pptx
+++ b/deck/Feature-Bug-Requests.pptx
@@ -13,10 +13,9 @@
     <p:sldId id="261" r:id="rId7"/>
     <p:sldId id="262" r:id="rId8"/>
     <p:sldId id="263" r:id="rId9"/>
-    <p:sldId id="264" r:id="rId10"/>
   </p:sldIdLst>
   <p:notesMasterIdLst>
-    <p:notesMasterId r:id="rId11"/>
+    <p:notesMasterId r:id="rId10"/>
   </p:notesMasterIdLst>
   <p:sldSz cx="9144000" cy="5143500"/>
   <p:notesSz cx="5143500" cy="9144000"/>
@@ -862,7 +861,7 @@
           <a:p>
             <a:r>
               <a:rPr lang="en-US" dirty="0"/>
-              <a:t>Agents. Two cheap reader agents, one per source, return structured records. The frontier editor agent reads existing themes first, then files each new claim: append or open, with one line of why. All nightly.</a:t>
+              <a:t>Agents. Two cheap reader agents, one per source, return structured records. Two gates in code: a PII scrub before any reader sees a word, and a schema plus an exact quote check before anything is stored. The frontier editor agent reads existing themes first, then files each new claim: append or open, with one line of why. A golden set runs every night so drift fails the job. All nightly.</a:t>
             </a:r>
             <a:endParaRPr lang="en-US" dirty="0"/>
           </a:p>
@@ -1038,7 +1037,7 @@
           <a:p>
             <a:r>
               <a:rPr lang="en-US" dirty="0"/>
-              <a:t>The questions from the panel, answered in the build. Where the context lives between runs, where the agents run and when Bedrock is the right swap, what an agent can see and do and how it is audited, the PII scrub before any reader, the golden set against drift, the library as plain files, and the cost on every run.</a:t>
+              <a:t>Scope. Built only what the brief asked for. A wider scrub, a wider golden set, live connectors and an approve gate are drawn on the system; a database, sign-in with memory, status per theme, weekly notes, more sources, per-account and trend views are listed for later. None of it is built.</a:t>
             </a:r>
             <a:endParaRPr lang="en-US" dirty="0"/>
           </a:p>
@@ -1126,7 +1125,7 @@
           <a:p>
             <a:r>
               <a:rPr lang="en-US" dirty="0"/>
-              <a:t>Scope. Built only what the brief asked for. A wider scrub, a wider golden set, live connectors and an approve gate are drawn on the system; a database, sign-in with memory, status per theme, weekly notes, more sources, per-account and trend views are listed for later. None of it is built.</a:t>
+              <a:t>Appendix. The stack, the model tiers, the size of the mock data, the checks in code including that every agent answers only through a schema, the hosting, and the first week of real numbers. Every one of these was a choice; the point is that nothing here is accidental.</a:t>
             </a:r>
             <a:endParaRPr lang="en-US" dirty="0"/>
           </a:p>
@@ -1150,94 +1149,6 @@
             <a:fld id="{F7021451-1387-4CA6-816F-3879F97B5CBC}" type="slidenum">
               <a:rPr lang="en-US"/>
               <a:t>8</a:t>
-            </a:fld>
-            <a:endParaRPr lang="en-US"/>
-          </a:p>
-        </p:txBody>
-      </p:sp>
-    </p:spTree>
-    <p:extLst>
-      <p:ext uri="{BB962C8B-B14F-4D97-AF65-F5344CB8AC3E}">
-        <p14:creationId xmlns:p14="http://schemas.microsoft.com/office/powerpoint/2010/main" val="1024086991"/>
-      </p:ext>
-    </p:extLst>
-  </p:cSld>
-  <p:clrMapOvr>
-    <a:masterClrMapping/>
-  </p:clrMapOvr>
-</p:notes>
-</file>
-
-<file path=ppt/notesSlides/notesSlide9.xml><?xml version="1.0" encoding="utf-8"?>
-<p:notes xmlns:a="http://schemas.openxmlformats.org/drawingml/2006/main" xmlns:r="http://schemas.openxmlformats.org/officeDocument/2006/relationships" xmlns:p="http://schemas.openxmlformats.org/presentationml/2006/main">
-  <p:cSld>
-    <p:spTree>
-      <p:nvGrpSpPr>
-        <p:cNvPr id="1" name=""/>
-        <p:cNvGrpSpPr/>
-        <p:nvPr/>
-      </p:nvGrpSpPr>
-      <p:grpSpPr>
-        <a:xfrm>
-          <a:off x="0" y="0"/>
-          <a:ext cx="0" cy="0"/>
-          <a:chOff x="0" y="0"/>
-          <a:chExt cx="0" cy="0"/>
-        </a:xfrm>
-      </p:grpSpPr>
-      <p:sp>
-        <p:nvSpPr>
-          <p:cNvPr id="2" name="Slide Image Placeholder 1"/>
-          <p:cNvSpPr>
-            <a:spLocks noGrp="1" noRot="1" noChangeAspect="1"/>
-          </p:cNvSpPr>
-          <p:nvPr>
-            <p:ph type="sldImg"/>
-          </p:nvPr>
-        </p:nvSpPr>
-        <p:spPr/>
-      </p:sp>
-      <p:sp>
-        <p:nvSpPr>
-          <p:cNvPr id="3" name="Notes Placeholder 2"/>
-          <p:cNvSpPr>
-            <a:spLocks noGrp="1"/>
-          </p:cNvSpPr>
-          <p:nvPr>
-            <p:ph type="body" idx="1"/>
-          </p:nvPr>
-        </p:nvSpPr>
-        <p:spPr/>
-        <p:txBody>
-          <a:bodyPr/>
-          <a:lstStyle/>
-          <a:p>
-            <a:r>
-              <a:rPr lang="en-US" dirty="0"/>
-              <a:t>Appendix. The stack, the model tiers, the size of the mock data, the checks in code including that every agent answers only through a schema, the hosting, and the first week of real numbers. Every one of these was a choice; the point is that nothing here is accidental.</a:t>
-            </a:r>
-            <a:endParaRPr lang="en-US" dirty="0"/>
-          </a:p>
-        </p:txBody>
-      </p:sp>
-      <p:sp>
-        <p:nvSpPr>
-          <p:cNvPr id="4" name="Slide Number Placeholder 3"/>
-          <p:cNvSpPr>
-            <a:spLocks noGrp="1"/>
-          </p:cNvSpPr>
-          <p:nvPr>
-            <p:ph type="sldNum" sz="quarter" idx="10"/>
-          </p:nvPr>
-        </p:nvSpPr>
-        <p:spPr/>
-        <p:txBody>
-          <a:bodyPr/>
-          <a:lstStyle/>
-          <a:p>
-            <a:fld id="{F7021451-1387-4CA6-816F-3879F97B5CBC}" type="slidenum">
-              <a:rPr lang="en-US"/>
-              <a:t>9</a:t>
             </a:fld>
             <a:endParaRPr lang="en-US"/>
           </a:p>
@@ -2233,7 +2144,7 @@
         <p:spPr>
           <a:xfrm>
             <a:off x="548640" y="1417320"/>
-            <a:ext cx="8046720" cy="2819705"/>
+            <a:ext cx="8046720" cy="2937053"/>
           </a:xfrm>
           <a:prstGeom prst="rect">
             <a:avLst/>
@@ -2478,7 +2389,7 @@
                 <a:ea typeface="Arial" pitchFamily="34" charset="-122"/>
                 <a:cs typeface="Arial" pitchFamily="34" charset="-120"/>
               </a:rPr>
-              <a:t>The questions from our conversation, and where each answer lives</a:t>
+              <a:t>Built to the brief; the next steps are designed, not built</a:t>
             </a:r>
             <a:endParaRPr lang="en-US" sz="2200" dirty="0"/>
           </a:p>
@@ -2501,7 +2412,7 @@
         <p:spPr>
           <a:xfrm>
             <a:off x="548640" y="1417320"/>
-            <a:ext cx="5407540" cy="3291840"/>
+            <a:ext cx="7085575" cy="3291840"/>
           </a:xfrm>
           <a:prstGeom prst="rect">
             <a:avLst/>
@@ -2612,7 +2523,7 @@
                 <a:ea typeface="Arial" pitchFamily="34" charset="-122"/>
                 <a:cs typeface="Arial" pitchFamily="34" charset="-120"/>
               </a:rPr>
-              <a:t>Built to the brief; the next steps are designed, not built</a:t>
+              <a:t>Appendix: the decisions behind it</a:t>
             </a:r>
             <a:endParaRPr lang="en-US" sz="2200" dirty="0"/>
           </a:p>
@@ -2635,141 +2546,7 @@
         <p:spPr>
           <a:xfrm>
             <a:off x="548640" y="1417320"/>
-            <a:ext cx="7085575" cy="3291840"/>
-          </a:xfrm>
-          <a:prstGeom prst="rect">
-            <a:avLst/>
-          </a:prstGeom>
-        </p:spPr>
-      </p:pic>
-    </p:spTree>
-  </p:cSld>
-  <p:clrMapOvr>
-    <a:masterClrMapping/>
-  </p:clrMapOvr>
-</p:sld>
-</file>
-
-<file path=ppt/slides/slide9.xml><?xml version="1.0" encoding="utf-8"?>
-<p:sld xmlns:a="http://schemas.openxmlformats.org/drawingml/2006/main" xmlns:r="http://schemas.openxmlformats.org/officeDocument/2006/relationships" xmlns:p="http://schemas.openxmlformats.org/presentationml/2006/main">
-  <p:cSld name="Slide 9">
-    <p:bg>
-      <p:bgPr>
-        <a:solidFill>
-          <a:srgbClr val="FFFFFF"/>
-        </a:solidFill>
-      </p:bgPr>
-    </p:bg>
-    <p:spTree>
-      <p:nvGrpSpPr>
-        <p:cNvPr id="1" name=""/>
-        <p:cNvGrpSpPr/>
-        <p:nvPr/>
-      </p:nvGrpSpPr>
-      <p:grpSpPr>
-        <a:xfrm>
-          <a:off x="0" y="0"/>
-          <a:ext cx="0" cy="0"/>
-          <a:chOff x="0" y="0"/>
-          <a:chExt cx="0" cy="0"/>
-        </a:xfrm>
-      </p:grpSpPr>
-      <p:sp>
-        <p:nvSpPr>
-          <p:cNvPr id="2" name="Text 0"/>
-          <p:cNvSpPr txBox="1"/>
-          <p:nvPr/>
-        </p:nvSpPr>
-        <p:spPr>
-          <a:xfrm>
-            <a:off x="8412480" y="182880"/>
-            <a:ext cx="457200" cy="274320"/>
-          </a:xfrm>
-          <a:prstGeom prst="rect">
-            <a:avLst/>
-          </a:prstGeom>
-          <a:noFill/>
-          <a:ln/>
-        </p:spPr>
-        <p:txBody>
-          <a:bodyPr wrap="square" lIns="0" tIns="0" rIns="0" bIns="0" rtlCol="0" anchor="ctr"/>
-          <a:lstStyle/>
-          <a:p>
-            <a:pPr algn="r" indent="0" marL="0">
-              <a:buNone/>
-            </a:pPr>
-            <a:r>
-              <a:rPr lang="en-US" sz="1000" dirty="0">
-                <a:solidFill>
-                  <a:srgbClr val="888780"/>
-                </a:solidFill>
-                <a:latin typeface="Arial" pitchFamily="34" charset="0"/>
-                <a:ea typeface="Arial" pitchFamily="34" charset="-122"/>
-                <a:cs typeface="Arial" pitchFamily="34" charset="-120"/>
-              </a:rPr>
-              <a:t>9</a:t>
-            </a:r>
-            <a:endParaRPr lang="en-US" sz="1000" dirty="0"/>
-          </a:p>
-        </p:txBody>
-      </p:sp>
-      <p:sp>
-        <p:nvSpPr>
-          <p:cNvPr id="3" name="Text 1"/>
-          <p:cNvSpPr txBox="1"/>
-          <p:nvPr/>
-        </p:nvSpPr>
-        <p:spPr>
-          <a:xfrm>
-            <a:off x="548640" y="411480"/>
-            <a:ext cx="8046720" cy="868680"/>
-          </a:xfrm>
-          <a:prstGeom prst="rect">
-            <a:avLst/>
-          </a:prstGeom>
-          <a:noFill/>
-          <a:ln/>
-        </p:spPr>
-        <p:txBody>
-          <a:bodyPr wrap="square" lIns="0" tIns="0" rIns="0" bIns="0" rtlCol="0" anchor="t"/>
-          <a:lstStyle/>
-          <a:p>
-            <a:pPr indent="0" marL="0">
-              <a:buNone/>
-            </a:pPr>
-            <a:r>
-              <a:rPr lang="en-US" sz="2200" dirty="0">
-                <a:solidFill>
-                  <a:srgbClr val="2C2C2A"/>
-                </a:solidFill>
-                <a:latin typeface="Arial" pitchFamily="34" charset="0"/>
-                <a:ea typeface="Arial" pitchFamily="34" charset="-122"/>
-                <a:cs typeface="Arial" pitchFamily="34" charset="-120"/>
-              </a:rPr>
-              <a:t>Appendix: the decisions behind it</a:t>
-            </a:r>
-            <a:endParaRPr lang="en-US" sz="2200" dirty="0"/>
-          </a:p>
-        </p:txBody>
-      </p:sp>
-      <p:pic>
-        <p:nvPicPr>
-          <p:cNvPr id="4" name="Image 0" descr="png/body/slide-9.png">    </p:cNvPr>
-          <p:cNvPicPr>
-            <a:picLocks noChangeAspect="1"/>
-          </p:cNvPicPr>
-          <p:nvPr/>
-        </p:nvPicPr>
-        <p:blipFill>
-          <a:blip r:embed="rId1"/>
-          <a:stretch>
-            <a:fillRect/>
-          </a:stretch>
-        </p:blipFill>
-        <p:spPr>
-          <a:xfrm>
-            <a:off x="548640" y="1417320"/>
-            <a:ext cx="6762354" cy="3291840"/>
+            <a:ext cx="6259982" cy="3291840"/>
           </a:xfrm>
           <a:prstGeom prst="rect">
             <a:avLst/>

</xml_diff>

<commit_message>
deck: hallucination slide, six checks in the order the data meets them
</commit_message>
<xml_diff>
--- a/deck/Feature-Bug-Requests.pptx
+++ b/deck/Feature-Bug-Requests.pptx
@@ -13,9 +13,10 @@
     <p:sldId id="261" r:id="rId7"/>
     <p:sldId id="262" r:id="rId8"/>
     <p:sldId id="263" r:id="rId9"/>
+    <p:sldId id="264" r:id="rId10"/>
   </p:sldIdLst>
   <p:notesMasterIdLst>
-    <p:notesMasterId r:id="rId10"/>
+    <p:notesMasterId r:id="rId11"/>
   </p:notesMasterIdLst>
   <p:sldSz cx="9144000" cy="5143500"/>
   <p:notesSz cx="5143500" cy="9144000"/>
@@ -1037,7 +1038,7 @@
           <a:p>
             <a:r>
               <a:rPr lang="en-US" dirty="0"/>
-              <a:t>Scope. Built only what the brief asked for. A wider scrub, a wider golden set, live connectors and an approve gate are drawn on the system; a database, sign-in with memory, status per theme, weekly notes, more sources, per-account and trend views are listed for later. None of it is built.</a:t>
+              <a:t>Hallucination. Six checks in the order the data meets them: exact quotes with a locator, a fixed schema so free text is impossible, a code check that the quote is in the cited source, a stated reason on every editor decision, an ask agent that knows only the library and says when it does not cover a question, and a golden set every night that fails the job on drift.</a:t>
             </a:r>
             <a:endParaRPr lang="en-US" dirty="0"/>
           </a:p>
@@ -1125,7 +1126,7 @@
           <a:p>
             <a:r>
               <a:rPr lang="en-US" dirty="0"/>
-              <a:t>Appendix. The stack, the model tiers, the size of the mock data, the checks in code including that every agent answers only through a schema, the hosting, and the first week of real numbers. Every one of these was a choice; the point is that nothing here is accidental.</a:t>
+              <a:t>Scope. Built only what the brief asked for. A wider scrub, a wider golden set, live connectors and an approve gate are drawn on the system; a database, sign-in with memory, status per theme, weekly notes, more sources, per-account and trend views are listed for later. None of it is built.</a:t>
             </a:r>
             <a:endParaRPr lang="en-US" dirty="0"/>
           </a:p>
@@ -1149,6 +1150,94 @@
             <a:fld id="{F7021451-1387-4CA6-816F-3879F97B5CBC}" type="slidenum">
               <a:rPr lang="en-US"/>
               <a:t>8</a:t>
+            </a:fld>
+            <a:endParaRPr lang="en-US"/>
+          </a:p>
+        </p:txBody>
+      </p:sp>
+    </p:spTree>
+    <p:extLst>
+      <p:ext uri="{BB962C8B-B14F-4D97-AF65-F5344CB8AC3E}">
+        <p14:creationId xmlns:p14="http://schemas.microsoft.com/office/powerpoint/2010/main" val="1024086991"/>
+      </p:ext>
+    </p:extLst>
+  </p:cSld>
+  <p:clrMapOvr>
+    <a:masterClrMapping/>
+  </p:clrMapOvr>
+</p:notes>
+</file>
+
+<file path=ppt/notesSlides/notesSlide9.xml><?xml version="1.0" encoding="utf-8"?>
+<p:notes xmlns:a="http://schemas.openxmlformats.org/drawingml/2006/main" xmlns:r="http://schemas.openxmlformats.org/officeDocument/2006/relationships" xmlns:p="http://schemas.openxmlformats.org/presentationml/2006/main">
+  <p:cSld>
+    <p:spTree>
+      <p:nvGrpSpPr>
+        <p:cNvPr id="1" name=""/>
+        <p:cNvGrpSpPr/>
+        <p:nvPr/>
+      </p:nvGrpSpPr>
+      <p:grpSpPr>
+        <a:xfrm>
+          <a:off x="0" y="0"/>
+          <a:ext cx="0" cy="0"/>
+          <a:chOff x="0" y="0"/>
+          <a:chExt cx="0" cy="0"/>
+        </a:xfrm>
+      </p:grpSpPr>
+      <p:sp>
+        <p:nvSpPr>
+          <p:cNvPr id="2" name="Slide Image Placeholder 1"/>
+          <p:cNvSpPr>
+            <a:spLocks noGrp="1" noRot="1" noChangeAspect="1"/>
+          </p:cNvSpPr>
+          <p:nvPr>
+            <p:ph type="sldImg"/>
+          </p:nvPr>
+        </p:nvSpPr>
+        <p:spPr/>
+      </p:sp>
+      <p:sp>
+        <p:nvSpPr>
+          <p:cNvPr id="3" name="Notes Placeholder 2"/>
+          <p:cNvSpPr>
+            <a:spLocks noGrp="1"/>
+          </p:cNvSpPr>
+          <p:nvPr>
+            <p:ph type="body" idx="1"/>
+          </p:nvPr>
+        </p:nvSpPr>
+        <p:spPr/>
+        <p:txBody>
+          <a:bodyPr/>
+          <a:lstStyle/>
+          <a:p>
+            <a:r>
+              <a:rPr lang="en-US" dirty="0"/>
+              <a:t>Appendix. The stack, the model tiers, the size of the mock data, the checks in code including that every agent answers only through a schema, the hosting, and the first week of real numbers. Every one of these was a choice; the point is that nothing here is accidental.</a:t>
+            </a:r>
+            <a:endParaRPr lang="en-US" dirty="0"/>
+          </a:p>
+        </p:txBody>
+      </p:sp>
+      <p:sp>
+        <p:nvSpPr>
+          <p:cNvPr id="4" name="Slide Number Placeholder 3"/>
+          <p:cNvSpPr>
+            <a:spLocks noGrp="1"/>
+          </p:cNvSpPr>
+          <p:nvPr>
+            <p:ph type="sldNum" sz="quarter" idx="10"/>
+          </p:nvPr>
+        </p:nvSpPr>
+        <p:spPr/>
+        <p:txBody>
+          <a:bodyPr/>
+          <a:lstStyle/>
+          <a:p>
+            <a:fld id="{F7021451-1387-4CA6-816F-3879F97B5CBC}" type="slidenum">
+              <a:rPr lang="en-US"/>
+              <a:t>9</a:t>
             </a:fld>
             <a:endParaRPr lang="en-US"/>
           </a:p>
@@ -2389,7 +2478,7 @@
                 <a:ea typeface="Arial" pitchFamily="34" charset="-122"/>
                 <a:cs typeface="Arial" pitchFamily="34" charset="-120"/>
               </a:rPr>
-              <a:t>Built to the brief; the next steps are designed, not built</a:t>
+              <a:t>Nothing invented can reach the page: six checks, in the order the data meets them</a:t>
             </a:r>
             <a:endParaRPr lang="en-US" sz="2200" dirty="0"/>
           </a:p>
@@ -2412,7 +2501,7 @@
         <p:spPr>
           <a:xfrm>
             <a:off x="548640" y="1417320"/>
-            <a:ext cx="7085575" cy="3291840"/>
+            <a:ext cx="8046720" cy="2743965"/>
           </a:xfrm>
           <a:prstGeom prst="rect">
             <a:avLst/>
@@ -2523,7 +2612,7 @@
                 <a:ea typeface="Arial" pitchFamily="34" charset="-122"/>
                 <a:cs typeface="Arial" pitchFamily="34" charset="-120"/>
               </a:rPr>
-              <a:t>Appendix: the decisions behind it</a:t>
+              <a:t>Built to the brief; the next steps are designed, not built</a:t>
             </a:r>
             <a:endParaRPr lang="en-US" sz="2200" dirty="0"/>
           </a:p>
@@ -2532,6 +2621,140 @@
       <p:pic>
         <p:nvPicPr>
           <p:cNvPr id="4" name="Image 0" descr="png/body/slide-8.png">    </p:cNvPr>
+          <p:cNvPicPr>
+            <a:picLocks noChangeAspect="1"/>
+          </p:cNvPicPr>
+          <p:nvPr/>
+        </p:nvPicPr>
+        <p:blipFill>
+          <a:blip r:embed="rId1"/>
+          <a:stretch>
+            <a:fillRect/>
+          </a:stretch>
+        </p:blipFill>
+        <p:spPr>
+          <a:xfrm>
+            <a:off x="548640" y="1417320"/>
+            <a:ext cx="7085575" cy="3291840"/>
+          </a:xfrm>
+          <a:prstGeom prst="rect">
+            <a:avLst/>
+          </a:prstGeom>
+        </p:spPr>
+      </p:pic>
+    </p:spTree>
+  </p:cSld>
+  <p:clrMapOvr>
+    <a:masterClrMapping/>
+  </p:clrMapOvr>
+</p:sld>
+</file>
+
+<file path=ppt/slides/slide9.xml><?xml version="1.0" encoding="utf-8"?>
+<p:sld xmlns:a="http://schemas.openxmlformats.org/drawingml/2006/main" xmlns:r="http://schemas.openxmlformats.org/officeDocument/2006/relationships" xmlns:p="http://schemas.openxmlformats.org/presentationml/2006/main">
+  <p:cSld name="Slide 9">
+    <p:bg>
+      <p:bgPr>
+        <a:solidFill>
+          <a:srgbClr val="FFFFFF"/>
+        </a:solidFill>
+      </p:bgPr>
+    </p:bg>
+    <p:spTree>
+      <p:nvGrpSpPr>
+        <p:cNvPr id="1" name=""/>
+        <p:cNvGrpSpPr/>
+        <p:nvPr/>
+      </p:nvGrpSpPr>
+      <p:grpSpPr>
+        <a:xfrm>
+          <a:off x="0" y="0"/>
+          <a:ext cx="0" cy="0"/>
+          <a:chOff x="0" y="0"/>
+          <a:chExt cx="0" cy="0"/>
+        </a:xfrm>
+      </p:grpSpPr>
+      <p:sp>
+        <p:nvSpPr>
+          <p:cNvPr id="2" name="Text 0"/>
+          <p:cNvSpPr txBox="1"/>
+          <p:nvPr/>
+        </p:nvSpPr>
+        <p:spPr>
+          <a:xfrm>
+            <a:off x="8412480" y="182880"/>
+            <a:ext cx="457200" cy="274320"/>
+          </a:xfrm>
+          <a:prstGeom prst="rect">
+            <a:avLst/>
+          </a:prstGeom>
+          <a:noFill/>
+          <a:ln/>
+        </p:spPr>
+        <p:txBody>
+          <a:bodyPr wrap="square" lIns="0" tIns="0" rIns="0" bIns="0" rtlCol="0" anchor="ctr"/>
+          <a:lstStyle/>
+          <a:p>
+            <a:pPr algn="r" indent="0" marL="0">
+              <a:buNone/>
+            </a:pPr>
+            <a:r>
+              <a:rPr lang="en-US" sz="1000" dirty="0">
+                <a:solidFill>
+                  <a:srgbClr val="888780"/>
+                </a:solidFill>
+                <a:latin typeface="Arial" pitchFamily="34" charset="0"/>
+                <a:ea typeface="Arial" pitchFamily="34" charset="-122"/>
+                <a:cs typeface="Arial" pitchFamily="34" charset="-120"/>
+              </a:rPr>
+              <a:t>9</a:t>
+            </a:r>
+            <a:endParaRPr lang="en-US" sz="1000" dirty="0"/>
+          </a:p>
+        </p:txBody>
+      </p:sp>
+      <p:sp>
+        <p:nvSpPr>
+          <p:cNvPr id="3" name="Text 1"/>
+          <p:cNvSpPr txBox="1"/>
+          <p:nvPr/>
+        </p:nvSpPr>
+        <p:spPr>
+          <a:xfrm>
+            <a:off x="548640" y="411480"/>
+            <a:ext cx="8046720" cy="868680"/>
+          </a:xfrm>
+          <a:prstGeom prst="rect">
+            <a:avLst/>
+          </a:prstGeom>
+          <a:noFill/>
+          <a:ln/>
+        </p:spPr>
+        <p:txBody>
+          <a:bodyPr wrap="square" lIns="0" tIns="0" rIns="0" bIns="0" rtlCol="0" anchor="t"/>
+          <a:lstStyle/>
+          <a:p>
+            <a:pPr indent="0" marL="0">
+              <a:buNone/>
+            </a:pPr>
+            <a:r>
+              <a:rPr lang="en-US" sz="2200" dirty="0">
+                <a:solidFill>
+                  <a:srgbClr val="2C2C2A"/>
+                </a:solidFill>
+                <a:latin typeface="Arial" pitchFamily="34" charset="0"/>
+                <a:ea typeface="Arial" pitchFamily="34" charset="-122"/>
+                <a:cs typeface="Arial" pitchFamily="34" charset="-120"/>
+              </a:rPr>
+              <a:t>Appendix: the decisions behind it</a:t>
+            </a:r>
+            <a:endParaRPr lang="en-US" sz="2200" dirty="0"/>
+          </a:p>
+        </p:txBody>
+      </p:sp>
+      <p:pic>
+        <p:nvPicPr>
+          <p:cNvPr id="4" name="Image 0" descr="png/body/slide-9.png">    </p:cNvPr>
           <p:cNvPicPr>
             <a:picLocks noChangeAspect="1"/>
           </p:cNvPicPr>

</xml_diff>

<commit_message>
Merge THEME-0012 into THEME-0011; code files an open whose title matches an existing theme; golden set covers the editor
The editor opened the identity-provider role-sync issue twice on 2026-09-16 under two titles. The library now holds one theme with both accounts. apply_decisions appends to any theme whose title shares most of its words with the one the editor wants to open, existing or opened tonight, and logs that code did it. A theme opened without a summary falls back to the claim topic. The golden set gains pairs from two accounts that must share one theme and a check that no two titles say the same thing. Deck slides 7 to 9 and the notes updated to match.
</commit_message>
<xml_diff>
--- a/deck/Feature-Bug-Requests.pptx
+++ b/deck/Feature-Bug-Requests.pptx
@@ -1038,7 +1038,7 @@
           <a:p>
             <a:r>
               <a:rPr lang="en-US" dirty="0"/>
-              <a:t>Hallucination. Six checks in the order the data meets them: exact quotes with a locator, a fixed schema so free text is impossible, a code check that the quote is in the cited source, a stated reason on every editor decision, an ask agent that knows only the library and says when it does not cover a question, and a golden set every night that fails the job on drift.</a:t>
+              <a:t>Hallucination. Six checks in the order the data meets them: exact quotes with a locator, a fixed schema so free text is impossible, a code check that the quote is in the cited source, a stated reason on every editor decision, an ask agent that knows only the library and says when it does not cover a question, and a golden set every night, covering how the editor files as well as the claims, that fails the job on drift.</a:t>
             </a:r>
             <a:endParaRPr lang="en-US" dirty="0"/>
           </a:p>
@@ -1126,7 +1126,7 @@
           <a:p>
             <a:r>
               <a:rPr lang="en-US" dirty="0"/>
-              <a:t>Scope. Built only what the brief asked for. A wider scrub, a wider golden set, live connectors and an approve gate are drawn on the system; a database, sign-in with memory, status per theme, weekly notes, more sources, per-account and trend views are listed for later. None of it is built.</a:t>
+              <a:t>Scope. Built only what the brief asked for. A wider scrub, live connectors and an approve gate are drawn on the system; a database, sign-in with memory, status per theme, weekly notes, more sources, per-account and trend views are listed for later. None of it is built.</a:t>
             </a:r>
             <a:endParaRPr lang="en-US" dirty="0"/>
           </a:p>
@@ -2501,7 +2501,7 @@
         <p:spPr>
           <a:xfrm>
             <a:off x="548640" y="1417320"/>
-            <a:ext cx="8046720" cy="2743965"/>
+            <a:ext cx="8046720" cy="2699131"/>
           </a:xfrm>
           <a:prstGeom prst="rect">
             <a:avLst/>
@@ -2635,7 +2635,7 @@
         <p:spPr>
           <a:xfrm>
             <a:off x="548640" y="1417320"/>
-            <a:ext cx="7085575" cy="3291840"/>
+            <a:ext cx="7188732" cy="3291840"/>
           </a:xfrm>
           <a:prstGeom prst="rect">
             <a:avLst/>
@@ -2769,7 +2769,7 @@
         <p:spPr>
           <a:xfrm>
             <a:off x="548640" y="1417320"/>
-            <a:ext cx="6259982" cy="3291840"/>
+            <a:ext cx="6322335" cy="3291840"/>
           </a:xfrm>
           <a:prstGeom prst="rect">
             <a:avLst/>

</xml_diff>